<commit_message>
Update packaged deliverables with official logo
Co-Authored-By: Claude Opus 5.5 <noreply@anthropic.com>
Claude-Session: https://claude.ai/code/session_013RnjHhJ6cLQsiGP7jjjop7
</commit_message>
<xml_diff>
--- a/deliverables/fazaa_presentation.pptx
+++ b/deliverables/fazaa_presentation.pptx
@@ -4805,9 +4805,55 @@
           </a:p>
         </p:txBody>
       </p:sp>
+      <p:sp>
+        <p:nvSpPr>
+          <p:cNvPr id="18" name="Rounded Rectangle 17"/>
+          <p:cNvSpPr/>
+          <p:nvPr/>
+        </p:nvSpPr>
+        <p:spPr>
+          <a:xfrm>
+            <a:off x="7635240" y="1463040"/>
+            <a:ext cx="3931920" cy="2743200"/>
+          </a:xfrm>
+          <a:prstGeom prst="roundRect">
+            <a:avLst>
+              <a:gd name="adj" fmla="val 12000"/>
+            </a:avLst>
+          </a:prstGeom>
+          <a:solidFill>
+            <a:srgbClr val="FFFFFF"/>
+          </a:solidFill>
+          <a:ln>
+            <a:noFill/>
+          </a:ln>
+          <a:effectLst/>
+        </p:spPr>
+        <p:style>
+          <a:lnRef idx="1">
+            <a:schemeClr val="accent1"/>
+          </a:lnRef>
+          <a:fillRef idx="3">
+            <a:schemeClr val="accent1"/>
+          </a:fillRef>
+          <a:effectRef idx="2">
+            <a:schemeClr val="accent1"/>
+          </a:effectRef>
+          <a:fontRef idx="minor">
+            <a:schemeClr val="lt1"/>
+          </a:fontRef>
+        </p:style>
+        <p:txBody>
+          <a:bodyPr rtlCol="0" anchor="ctr"/>
+          <a:lstStyle/>
+          <a:p>
+            <a:pPr algn="ctr"/>
+          </a:p>
+        </p:txBody>
+      </p:sp>
       <p:pic>
         <p:nvPicPr>
-          <p:cNvPr id="18" name="Picture 17" descr="logo.png"/>
+          <p:cNvPr id="19" name="Picture 18" descr="logo_full.png"/>
           <p:cNvPicPr>
             <a:picLocks noChangeAspect="1"/>
           </p:cNvPicPr>
@@ -4821,8 +4867,8 @@
         </p:blipFill>
         <p:spPr>
           <a:xfrm>
-            <a:off x="8229600" y="1234440"/>
-            <a:ext cx="3657600" cy="4206240"/>
+            <a:off x="7818120" y="1627632"/>
+            <a:ext cx="3566160" cy="2107568"/>
           </a:xfrm>
           <a:prstGeom prst="rect">
             <a:avLst/>
@@ -4831,7 +4877,7 @@
       </p:pic>
       <p:sp>
         <p:nvSpPr>
-          <p:cNvPr id="19" name="TextBox 18"/>
+          <p:cNvPr id="20" name="TextBox 19"/>
           <p:cNvSpPr txBox="1"/>
           <p:nvPr/>
         </p:nvSpPr>
@@ -4911,7 +4957,7 @@
         <p:spPr>
           <a:xfrm>
             <a:off x="11274552" y="274320"/>
-            <a:ext cx="492981" cy="566928"/>
+            <a:ext cx="527830" cy="566928"/>
           </a:xfrm>
           <a:prstGeom prst="rect">
             <a:avLst/>
@@ -5637,7 +5683,7 @@
         <p:spPr>
           <a:xfrm>
             <a:off x="11274552" y="274320"/>
-            <a:ext cx="492981" cy="566928"/>
+            <a:ext cx="527830" cy="566928"/>
           </a:xfrm>
           <a:prstGeom prst="rect">
             <a:avLst/>
@@ -6347,7 +6393,7 @@
         <p:spPr>
           <a:xfrm>
             <a:off x="11274552" y="274320"/>
-            <a:ext cx="492981" cy="566928"/>
+            <a:ext cx="527830" cy="566928"/>
           </a:xfrm>
           <a:prstGeom prst="rect">
             <a:avLst/>
@@ -6454,7 +6500,7 @@
         <p:spPr>
           <a:xfrm>
             <a:off x="11274552" y="274320"/>
-            <a:ext cx="492981" cy="566928"/>
+            <a:ext cx="527830" cy="566928"/>
           </a:xfrm>
           <a:prstGeom prst="rect">
             <a:avLst/>
@@ -7290,7 +7336,7 @@
         <p:spPr>
           <a:xfrm>
             <a:off x="11274552" y="274320"/>
-            <a:ext cx="492981" cy="566928"/>
+            <a:ext cx="527830" cy="566928"/>
           </a:xfrm>
           <a:prstGeom prst="rect">
             <a:avLst/>
@@ -8585,7 +8631,7 @@
         <p:spPr>
           <a:xfrm>
             <a:off x="11274552" y="274320"/>
-            <a:ext cx="492981" cy="566928"/>
+            <a:ext cx="527830" cy="566928"/>
           </a:xfrm>
           <a:prstGeom prst="rect">
             <a:avLst/>
@@ -10761,7 +10807,7 @@
         <p:spPr>
           <a:xfrm>
             <a:off x="11274552" y="274320"/>
-            <a:ext cx="492981" cy="566928"/>
+            <a:ext cx="527830" cy="566928"/>
           </a:xfrm>
           <a:prstGeom prst="rect">
             <a:avLst/>
@@ -11612,7 +11658,7 @@
         <p:spPr>
           <a:xfrm>
             <a:off x="11274552" y="274320"/>
-            <a:ext cx="492981" cy="566928"/>
+            <a:ext cx="527830" cy="566928"/>
           </a:xfrm>
           <a:prstGeom prst="rect">
             <a:avLst/>
@@ -12486,7 +12532,7 @@
         <p:spPr>
           <a:xfrm>
             <a:off x="11274552" y="274320"/>
-            <a:ext cx="492981" cy="566928"/>
+            <a:ext cx="527830" cy="566928"/>
           </a:xfrm>
           <a:prstGeom prst="rect">
             <a:avLst/>
@@ -13229,7 +13275,7 @@
         <p:spPr>
           <a:xfrm>
             <a:off x="11274552" y="274320"/>
-            <a:ext cx="492981" cy="566928"/>
+            <a:ext cx="527830" cy="566928"/>
           </a:xfrm>
           <a:prstGeom prst="rect">
             <a:avLst/>

</xml_diff>